<commit_message>
design of pvtdata collection
Signed-off-by: senthil <cendhu@gmail.com>
</commit_message>
<xml_diff>
--- a/fig/proposed-pdc-flow.pptx
+++ b/fig/proposed-pdc-flow.pptx
@@ -104,6 +104,11 @@
       </a:defRPr>
     </a:lvl9pPr>
   </p:defaultTextStyle>
+  <p:extLst>
+    <p:ext uri="{EFAFB233-063F-42B5-8137-9DF3F51BA10A}">
+      <p15:sldGuideLst xmlns:p15="http://schemas.microsoft.com/office/powerpoint/2012/main"/>
+    </p:ext>
+  </p:extLst>
 </p:presentation>
 </file>
 
@@ -256,7 +261,7 @@
           <a:p>
             <a:fld id="{1A240C8B-7636-4C4C-9FA7-4342706BC1AA}" type="datetimeFigureOut">
               <a:rPr lang="en-US" smtClean="0"/>
-              <a:t>12/15/20</a:t>
+              <a:t>1/7/21</a:t>
             </a:fld>
             <a:endParaRPr lang="en-US"/>
           </a:p>
@@ -456,7 +461,7 @@
           <a:p>
             <a:fld id="{1A240C8B-7636-4C4C-9FA7-4342706BC1AA}" type="datetimeFigureOut">
               <a:rPr lang="en-US" smtClean="0"/>
-              <a:t>12/15/20</a:t>
+              <a:t>1/7/21</a:t>
             </a:fld>
             <a:endParaRPr lang="en-US"/>
           </a:p>
@@ -666,7 +671,7 @@
           <a:p>
             <a:fld id="{1A240C8B-7636-4C4C-9FA7-4342706BC1AA}" type="datetimeFigureOut">
               <a:rPr lang="en-US" smtClean="0"/>
-              <a:t>12/15/20</a:t>
+              <a:t>1/7/21</a:t>
             </a:fld>
             <a:endParaRPr lang="en-US"/>
           </a:p>
@@ -866,7 +871,7 @@
           <a:p>
             <a:fld id="{1A240C8B-7636-4C4C-9FA7-4342706BC1AA}" type="datetimeFigureOut">
               <a:rPr lang="en-US" smtClean="0"/>
-              <a:t>12/15/20</a:t>
+              <a:t>1/7/21</a:t>
             </a:fld>
             <a:endParaRPr lang="en-US"/>
           </a:p>
@@ -1142,7 +1147,7 @@
           <a:p>
             <a:fld id="{1A240C8B-7636-4C4C-9FA7-4342706BC1AA}" type="datetimeFigureOut">
               <a:rPr lang="en-US" smtClean="0"/>
-              <a:t>12/15/20</a:t>
+              <a:t>1/7/21</a:t>
             </a:fld>
             <a:endParaRPr lang="en-US"/>
           </a:p>
@@ -1410,7 +1415,7 @@
           <a:p>
             <a:fld id="{1A240C8B-7636-4C4C-9FA7-4342706BC1AA}" type="datetimeFigureOut">
               <a:rPr lang="en-US" smtClean="0"/>
-              <a:t>12/15/20</a:t>
+              <a:t>1/7/21</a:t>
             </a:fld>
             <a:endParaRPr lang="en-US"/>
           </a:p>
@@ -1825,7 +1830,7 @@
           <a:p>
             <a:fld id="{1A240C8B-7636-4C4C-9FA7-4342706BC1AA}" type="datetimeFigureOut">
               <a:rPr lang="en-US" smtClean="0"/>
-              <a:t>12/15/20</a:t>
+              <a:t>1/7/21</a:t>
             </a:fld>
             <a:endParaRPr lang="en-US"/>
           </a:p>
@@ -1967,7 +1972,7 @@
           <a:p>
             <a:fld id="{1A240C8B-7636-4C4C-9FA7-4342706BC1AA}" type="datetimeFigureOut">
               <a:rPr lang="en-US" smtClean="0"/>
-              <a:t>12/15/20</a:t>
+              <a:t>1/7/21</a:t>
             </a:fld>
             <a:endParaRPr lang="en-US"/>
           </a:p>
@@ -2080,7 +2085,7 @@
           <a:p>
             <a:fld id="{1A240C8B-7636-4C4C-9FA7-4342706BC1AA}" type="datetimeFigureOut">
               <a:rPr lang="en-US" smtClean="0"/>
-              <a:t>12/15/20</a:t>
+              <a:t>1/7/21</a:t>
             </a:fld>
             <a:endParaRPr lang="en-US"/>
           </a:p>
@@ -2393,7 +2398,7 @@
           <a:p>
             <a:fld id="{1A240C8B-7636-4C4C-9FA7-4342706BC1AA}" type="datetimeFigureOut">
               <a:rPr lang="en-US" smtClean="0"/>
-              <a:t>12/15/20</a:t>
+              <a:t>1/7/21</a:t>
             </a:fld>
             <a:endParaRPr lang="en-US"/>
           </a:p>
@@ -2682,7 +2687,7 @@
           <a:p>
             <a:fld id="{1A240C8B-7636-4C4C-9FA7-4342706BC1AA}" type="datetimeFigureOut">
               <a:rPr lang="en-US" smtClean="0"/>
-              <a:t>12/15/20</a:t>
+              <a:t>1/7/21</a:t>
             </a:fld>
             <a:endParaRPr lang="en-US"/>
           </a:p>
@@ -2925,7 +2930,7 @@
           <a:p>
             <a:fld id="{1A240C8B-7636-4C4C-9FA7-4342706BC1AA}" type="datetimeFigureOut">
               <a:rPr lang="en-US" smtClean="0"/>
-              <a:t>12/15/20</a:t>
+              <a:t>1/7/21</a:t>
             </a:fld>
             <a:endParaRPr lang="en-US"/>
           </a:p>
@@ -3486,7 +3491,7 @@
         </p:nvCxnSpPr>
         <p:spPr>
           <a:xfrm>
-            <a:off x="9559680" y="1055984"/>
+            <a:off x="9639192" y="1055984"/>
             <a:ext cx="0" cy="4608000"/>
           </a:xfrm>
           <a:prstGeom prst="line">
@@ -3995,7 +4000,7 @@
         </p:nvSpPr>
         <p:spPr>
           <a:xfrm>
-            <a:off x="9139147" y="702427"/>
+            <a:off x="9218659" y="702427"/>
             <a:ext cx="880369" cy="369332"/>
           </a:xfrm>
           <a:custGeom>
@@ -4356,7 +4361,7 @@
         <p:spPr>
           <a:xfrm>
             <a:off x="3309553" y="1135181"/>
-            <a:ext cx="2024895" cy="369332"/>
+            <a:ext cx="2024895" cy="384721"/>
           </a:xfrm>
           <a:prstGeom prst="rect">
             <a:avLst/>
@@ -4370,7 +4375,7 @@
           <a:lstStyle/>
           <a:p>
             <a:r>
-              <a:rPr lang="en-US" dirty="0">
+              <a:rPr lang="en-US" sz="1900" dirty="0">
                 <a:solidFill>
                   <a:schemeClr val="bg2">
                     <a:lumMod val="50000"/>
@@ -4382,7 +4387,7 @@
               <a:t>[T</a:t>
             </a:r>
             <a:r>
-              <a:rPr lang="en-US" baseline="-25000" dirty="0">
+              <a:rPr lang="en-US" sz="1900" baseline="-25000" dirty="0">
                 <a:solidFill>
                   <a:schemeClr val="bg2">
                     <a:lumMod val="50000"/>
@@ -4394,7 +4399,7 @@
               <a:t>i</a:t>
             </a:r>
             <a:r>
-              <a:rPr lang="en-US" dirty="0">
+              <a:rPr lang="en-US" sz="1900" dirty="0">
                 <a:solidFill>
                   <a:schemeClr val="bg2">
                     <a:lumMod val="50000"/>
@@ -4405,7 +4410,7 @@
               </a:rPr>
               <a:t>, Private Data] </a:t>
             </a:r>
-            <a:endParaRPr lang="en-US" baseline="-25000" dirty="0">
+            <a:endParaRPr lang="en-US" sz="1900" baseline="-25000" dirty="0">
               <a:solidFill>
                 <a:schemeClr val="bg2">
                   <a:lumMod val="50000"/>
@@ -4433,8 +4438,8 @@
         </p:nvCxnSpPr>
         <p:spPr>
           <a:xfrm flipH="1">
-            <a:off x="9572046" y="3842210"/>
-            <a:ext cx="1098327" cy="0"/>
+            <a:off x="9648000" y="3840064"/>
+            <a:ext cx="1008000" cy="0"/>
           </a:xfrm>
           <a:prstGeom prst="straightConnector1">
             <a:avLst/>
@@ -4569,7 +4574,7 @@
         <p:spPr>
           <a:xfrm>
             <a:off x="9762120" y="3424777"/>
-            <a:ext cx="1499128" cy="369332"/>
+            <a:ext cx="1568058" cy="384721"/>
           </a:xfrm>
           <a:prstGeom prst="rect">
             <a:avLst/>
@@ -4583,7 +4588,7 @@
           <a:lstStyle/>
           <a:p>
             <a:r>
-              <a:rPr lang="en-US" dirty="0">
+              <a:rPr lang="en-US" sz="1900" dirty="0">
                 <a:solidFill>
                   <a:schemeClr val="bg2">
                     <a:lumMod val="50000"/>
@@ -4612,7 +4617,7 @@
         <p:spPr>
           <a:xfrm>
             <a:off x="8310017" y="3577326"/>
-            <a:ext cx="697627" cy="369332"/>
+            <a:ext cx="724878" cy="384721"/>
           </a:xfrm>
           <a:prstGeom prst="rect">
             <a:avLst/>
@@ -4626,7 +4631,7 @@
           <a:lstStyle/>
           <a:p>
             <a:r>
-              <a:rPr lang="en-US" dirty="0">
+              <a:rPr lang="en-US" sz="1900" dirty="0">
                 <a:solidFill>
                   <a:schemeClr val="bg2">
                     <a:lumMod val="50000"/>
@@ -4654,8 +4659,8 @@
         </p:nvSpPr>
         <p:spPr>
           <a:xfrm>
-            <a:off x="4557413" y="5556690"/>
-            <a:ext cx="3997636" cy="369332"/>
+            <a:off x="5217588" y="5568722"/>
+            <a:ext cx="3997636" cy="384721"/>
           </a:xfrm>
           <a:prstGeom prst="rect">
             <a:avLst/>
@@ -4670,7 +4675,7 @@
           <a:p>
             <a:pPr algn="ctr"/>
             <a:r>
-              <a:rPr lang="en-US" dirty="0">
+              <a:rPr lang="en-US" sz="1900" dirty="0">
                 <a:solidFill>
                   <a:schemeClr val="bg2">
                     <a:lumMod val="50000"/>
@@ -4741,7 +4746,7 @@
           <a:p>
             <a:pPr algn="ctr"/>
             <a:r>
-              <a:rPr lang="en-US" sz="1400" dirty="0"/>
+              <a:rPr lang="en-US" sz="1700" dirty="0"/>
               <a:t>1</a:t>
             </a:r>
           </a:p>
@@ -4804,7 +4809,7 @@
           <a:p>
             <a:pPr algn="ctr"/>
             <a:r>
-              <a:rPr lang="en-US" sz="1400" dirty="0"/>
+              <a:rPr lang="en-US" sz="1700" dirty="0"/>
               <a:t>6</a:t>
             </a:r>
           </a:p>
@@ -4867,7 +4872,7 @@
           <a:p>
             <a:pPr algn="ctr"/>
             <a:r>
-              <a:rPr lang="en-US" sz="1400" dirty="0"/>
+              <a:rPr lang="en-US" sz="1700" dirty="0"/>
               <a:t>7</a:t>
             </a:r>
           </a:p>
@@ -4887,7 +4892,7 @@
         </p:nvSpPr>
         <p:spPr>
           <a:xfrm>
-            <a:off x="9465689" y="3587104"/>
+            <a:off x="9545201" y="3587104"/>
             <a:ext cx="185195" cy="206143"/>
           </a:xfrm>
           <a:prstGeom prst="ellipse">
@@ -4930,7 +4935,7 @@
           <a:p>
             <a:pPr algn="ctr"/>
             <a:r>
-              <a:rPr lang="en-US" sz="1400" dirty="0"/>
+              <a:rPr lang="en-US" sz="1700" dirty="0"/>
               <a:t>7</a:t>
             </a:r>
           </a:p>
@@ -4993,7 +4998,7 @@
           <a:p>
             <a:pPr algn="ctr"/>
             <a:r>
-              <a:rPr lang="en-US" sz="1400" dirty="0"/>
+              <a:rPr lang="en-US" sz="1700" dirty="0"/>
               <a:t>7</a:t>
             </a:r>
           </a:p>
@@ -5014,7 +5019,7 @@
         <p:spPr>
           <a:xfrm>
             <a:off x="6929358" y="4258677"/>
-            <a:ext cx="2518638" cy="369332"/>
+            <a:ext cx="2642070" cy="384721"/>
           </a:xfrm>
           <a:prstGeom prst="rect">
             <a:avLst/>
@@ -5028,7 +5033,7 @@
           <a:lstStyle/>
           <a:p>
             <a:r>
-              <a:rPr lang="en-US" dirty="0">
+              <a:rPr lang="en-US" sz="1900" dirty="0">
                 <a:solidFill>
                   <a:schemeClr val="bg2">
                     <a:lumMod val="50000"/>
@@ -5099,7 +5104,7 @@
           <a:p>
             <a:pPr algn="ctr"/>
             <a:r>
-              <a:rPr lang="en-US" sz="1400" dirty="0"/>
+              <a:rPr lang="en-US" sz="1700" dirty="0"/>
               <a:t>8</a:t>
             </a:r>
           </a:p>
@@ -5162,7 +5167,7 @@
           <a:p>
             <a:pPr algn="ctr"/>
             <a:r>
-              <a:rPr lang="en-US" sz="1400" dirty="0"/>
+              <a:rPr lang="en-US" sz="1700" dirty="0"/>
               <a:t>8</a:t>
             </a:r>
           </a:p>
@@ -5182,7 +5187,7 @@
         </p:nvSpPr>
         <p:spPr>
           <a:xfrm>
-            <a:off x="9465126" y="4131746"/>
+            <a:off x="9544638" y="4131746"/>
             <a:ext cx="185195" cy="206143"/>
           </a:xfrm>
           <a:prstGeom prst="ellipse">
@@ -5225,7 +5230,7 @@
           <a:p>
             <a:pPr algn="ctr"/>
             <a:r>
-              <a:rPr lang="en-US" sz="1400" dirty="0"/>
+              <a:rPr lang="en-US" sz="1700" dirty="0"/>
               <a:t>8</a:t>
             </a:r>
           </a:p>
@@ -5382,7 +5387,7 @@
           <a:p>
             <a:pPr algn="ctr"/>
             <a:r>
-              <a:rPr lang="en-US" sz="1400" dirty="0"/>
+              <a:rPr lang="en-US" sz="1700" dirty="0"/>
               <a:t>2</a:t>
             </a:r>
           </a:p>
@@ -5402,8 +5407,8 @@
         </p:nvSpPr>
         <p:spPr>
           <a:xfrm>
-            <a:off x="5772280" y="1421132"/>
-            <a:ext cx="1197764" cy="923330"/>
+            <a:off x="5709733" y="1421132"/>
+            <a:ext cx="1250663" cy="969496"/>
           </a:xfrm>
           <a:prstGeom prst="rect">
             <a:avLst/>
@@ -5418,7 +5423,7 @@
           <a:p>
             <a:pPr algn="ctr"/>
             <a:r>
-              <a:rPr lang="en-US" dirty="0">
+              <a:rPr lang="en-US" sz="1900" dirty="0">
                 <a:solidFill>
                   <a:schemeClr val="bg2">
                     <a:lumMod val="50000"/>
@@ -5433,7 +5438,7 @@
           <a:p>
             <a:pPr algn="ctr"/>
             <a:r>
-              <a:rPr lang="en-US" dirty="0">
+              <a:rPr lang="en-US" sz="1900" dirty="0">
                 <a:solidFill>
                   <a:schemeClr val="bg2">
                     <a:lumMod val="50000"/>
@@ -5448,7 +5453,7 @@
           <a:p>
             <a:pPr algn="ctr"/>
             <a:r>
-              <a:rPr lang="en-US" dirty="0">
+              <a:rPr lang="en-US" sz="1900" dirty="0">
                 <a:solidFill>
                   <a:schemeClr val="bg2">
                     <a:lumMod val="50000"/>
@@ -5519,7 +5524,7 @@
           <a:p>
             <a:pPr algn="ctr"/>
             <a:r>
-              <a:rPr lang="en-US" sz="1400" dirty="0"/>
+              <a:rPr lang="en-US" sz="1700" dirty="0"/>
               <a:t>4</a:t>
             </a:r>
           </a:p>
@@ -5539,8 +5544,8 @@
         </p:nvSpPr>
         <p:spPr>
           <a:xfrm>
-            <a:off x="2494739" y="2861652"/>
-            <a:ext cx="9006333" cy="369332"/>
+            <a:off x="2542865" y="2861652"/>
+            <a:ext cx="9006333" cy="677108"/>
           </a:xfrm>
           <a:prstGeom prst="rect">
             <a:avLst/>
@@ -5555,7 +5560,7 @@
           <a:p>
             <a:pPr algn="ctr"/>
             <a:r>
-              <a:rPr lang="en-US" dirty="0">
+              <a:rPr lang="en-US" sz="1900" dirty="0">
                 <a:solidFill>
                   <a:schemeClr val="bg2">
                     <a:lumMod val="50000"/>
@@ -5567,7 +5572,7 @@
               <a:t>response [T</a:t>
             </a:r>
             <a:r>
-              <a:rPr lang="en-US" baseline="-25000" dirty="0">
+              <a:rPr lang="en-US" sz="1900" baseline="-25000" dirty="0">
                 <a:solidFill>
                   <a:schemeClr val="bg2">
                     <a:lumMod val="50000"/>
@@ -5579,7 +5584,7 @@
               <a:t>i</a:t>
             </a:r>
             <a:r>
-              <a:rPr lang="en-US" dirty="0">
+              <a:rPr lang="en-US" sz="1900" dirty="0">
                 <a:solidFill>
                   <a:schemeClr val="bg2">
                     <a:lumMod val="50000"/>
@@ -5588,7 +5593,30 @@
                 <a:latin typeface="Times New Roman" panose="02020603050405020304" pitchFamily="18" charset="0"/>
                 <a:cs typeface="Times New Roman" panose="02020603050405020304" pitchFamily="18" charset="0"/>
               </a:rPr>
-              <a:t>, Public Data Read-Write Set, Hashed Data Read-Write Set, Endorsements]</a:t>
+              <a:t>, Public Data Read-Write Set, Hashed Data Read-Write Set, </a:t>
+            </a:r>
+            <a:br>
+              <a:rPr lang="en-US" sz="1900" dirty="0">
+                <a:solidFill>
+                  <a:schemeClr val="bg2">
+                    <a:lumMod val="50000"/>
+                  </a:schemeClr>
+                </a:solidFill>
+                <a:latin typeface="Times New Roman" panose="02020603050405020304" pitchFamily="18" charset="0"/>
+                <a:cs typeface="Times New Roman" panose="02020603050405020304" pitchFamily="18" charset="0"/>
+              </a:rPr>
+            </a:br>
+            <a:r>
+              <a:rPr lang="en-US" sz="1900" dirty="0">
+                <a:solidFill>
+                  <a:schemeClr val="bg2">
+                    <a:lumMod val="50000"/>
+                  </a:schemeClr>
+                </a:solidFill>
+                <a:latin typeface="Times New Roman" panose="02020603050405020304" pitchFamily="18" charset="0"/>
+                <a:cs typeface="Times New Roman" panose="02020603050405020304" pitchFamily="18" charset="0"/>
+              </a:rPr>
+              <a:t>Endorsements]</a:t>
             </a:r>
           </a:p>
         </p:txBody>
@@ -5607,8 +5635,8 @@
         </p:nvSpPr>
         <p:spPr>
           <a:xfrm>
-            <a:off x="2856736" y="1649250"/>
-            <a:ext cx="3075265" cy="1200329"/>
+            <a:off x="2780048" y="1649250"/>
+            <a:ext cx="3228641" cy="1261884"/>
           </a:xfrm>
           <a:prstGeom prst="rect">
             <a:avLst/>
@@ -5623,7 +5651,7 @@
           <a:p>
             <a:pPr algn="ctr"/>
             <a:r>
-              <a:rPr lang="en-US" dirty="0">
+              <a:rPr lang="en-US" sz="1900" dirty="0">
                 <a:solidFill>
                   <a:schemeClr val="bg2">
                     <a:lumMod val="50000"/>
@@ -5635,7 +5663,7 @@
               <a:t>response [T</a:t>
             </a:r>
             <a:r>
-              <a:rPr lang="en-US" baseline="-25000" dirty="0">
+              <a:rPr lang="en-US" sz="1900" baseline="-25000" dirty="0">
                 <a:solidFill>
                   <a:schemeClr val="bg2">
                     <a:lumMod val="50000"/>
@@ -5647,7 +5675,7 @@
               <a:t>i</a:t>
             </a:r>
             <a:r>
-              <a:rPr lang="en-US" dirty="0">
+              <a:rPr lang="en-US" sz="1900" dirty="0">
                 <a:solidFill>
                   <a:schemeClr val="bg2">
                     <a:lumMod val="50000"/>
@@ -5659,7 +5687,7 @@
               <a:t>, </a:t>
             </a:r>
             <a:br>
-              <a:rPr lang="en-US" dirty="0">
+              <a:rPr lang="en-US" sz="1900" dirty="0">
                 <a:solidFill>
                   <a:schemeClr val="bg2">
                     <a:lumMod val="50000"/>
@@ -5670,7 +5698,7 @@
               </a:rPr>
             </a:br>
             <a:r>
-              <a:rPr lang="en-US" dirty="0">
+              <a:rPr lang="en-US" sz="1900" dirty="0">
                 <a:solidFill>
                   <a:schemeClr val="bg2">
                     <a:lumMod val="50000"/>
@@ -5685,7 +5713,7 @@
           <a:p>
             <a:pPr algn="ctr"/>
             <a:r>
-              <a:rPr lang="en-US" dirty="0">
+              <a:rPr lang="en-US" sz="1900" dirty="0">
                 <a:solidFill>
                   <a:schemeClr val="bg2">
                     <a:lumMod val="50000"/>
@@ -5700,7 +5728,7 @@
           <a:p>
             <a:pPr algn="ctr"/>
             <a:r>
-              <a:rPr lang="en-US" dirty="0">
+              <a:rPr lang="en-US" sz="1900" dirty="0">
                 <a:solidFill>
                   <a:schemeClr val="bg2">
                     <a:lumMod val="50000"/>
@@ -6160,8 +6188,8 @@
         </p:nvCxnSpPr>
         <p:spPr>
           <a:xfrm rot="16200000" flipV="1">
-            <a:off x="5241444" y="291413"/>
-            <a:ext cx="1151372" cy="1108065"/>
+            <a:off x="5223395" y="309462"/>
+            <a:ext cx="1151372" cy="1071968"/>
           </a:xfrm>
           <a:prstGeom prst="curvedConnector3">
             <a:avLst>
@@ -6207,8 +6235,8 @@
         </p:nvSpPr>
         <p:spPr>
           <a:xfrm>
-            <a:off x="4603374" y="-42290"/>
-            <a:ext cx="2157385" cy="369332"/>
+            <a:off x="3673201" y="-42290"/>
+            <a:ext cx="3150799" cy="384721"/>
           </a:xfrm>
           <a:prstGeom prst="rect">
             <a:avLst/>
@@ -6222,7 +6250,7 @@
           <a:lstStyle/>
           <a:p>
             <a:r>
-              <a:rPr lang="en-US" i="1" dirty="0">
+              <a:rPr lang="en-US" sz="1900" i="1" dirty="0">
                 <a:solidFill>
                   <a:schemeClr val="bg1">
                     <a:lumMod val="50000"/>
@@ -6231,7 +6259,7 @@
                 <a:latin typeface="Times New Roman" panose="02020603050405020304" pitchFamily="18" charset="0"/>
                 <a:cs typeface="Times New Roman" panose="02020603050405020304" pitchFamily="18" charset="0"/>
               </a:rPr>
-              <a:t>store the private data</a:t>
+              <a:t>store the private data write set</a:t>
             </a:r>
           </a:p>
         </p:txBody>
@@ -6299,8 +6327,8 @@
         </p:nvSpPr>
         <p:spPr>
           <a:xfrm>
-            <a:off x="7018464" y="1632467"/>
-            <a:ext cx="2185214" cy="646331"/>
+            <a:off x="6971166" y="1585169"/>
+            <a:ext cx="2850460" cy="677108"/>
           </a:xfrm>
           <a:prstGeom prst="rect">
             <a:avLst/>
@@ -6314,7 +6342,7 @@
           <a:lstStyle/>
           <a:p>
             <a:r>
-              <a:rPr lang="en-US" i="1" dirty="0">
+              <a:rPr lang="en-US" sz="1900" i="1" dirty="0">
                 <a:solidFill>
                   <a:schemeClr val="bg1">
                     <a:lumMod val="50000"/>
@@ -6323,10 +6351,10 @@
                 <a:latin typeface="Times New Roman" panose="02020603050405020304" pitchFamily="18" charset="0"/>
                 <a:cs typeface="Times New Roman" panose="02020603050405020304" pitchFamily="18" charset="0"/>
               </a:rPr>
-              <a:t>send the private data </a:t>
+              <a:t>send the private data write </a:t>
             </a:r>
             <a:br>
-              <a:rPr lang="en-US" i="1" dirty="0">
+              <a:rPr lang="en-US" sz="1900" i="1" dirty="0">
                 <a:solidFill>
                   <a:schemeClr val="bg1">
                     <a:lumMod val="50000"/>
@@ -6337,7 +6365,7 @@
               </a:rPr>
             </a:br>
             <a:r>
-              <a:rPr lang="en-US" i="1" dirty="0">
+              <a:rPr lang="en-US" sz="1900" i="1" dirty="0">
                 <a:solidFill>
                   <a:schemeClr val="bg1">
                     <a:lumMod val="50000"/>
@@ -6346,7 +6374,7 @@
                 <a:latin typeface="Times New Roman" panose="02020603050405020304" pitchFamily="18" charset="0"/>
                 <a:cs typeface="Times New Roman" panose="02020603050405020304" pitchFamily="18" charset="0"/>
               </a:rPr>
-              <a:t>to PDC members</a:t>
+              <a:t>set to PDC members</a:t>
             </a:r>
           </a:p>
         </p:txBody>
@@ -6417,7 +6445,7 @@
         <p:spPr>
           <a:xfrm>
             <a:off x="7382093" y="958504"/>
-            <a:ext cx="1871025" cy="646331"/>
+            <a:ext cx="2255746" cy="677108"/>
           </a:xfrm>
           <a:prstGeom prst="rect">
             <a:avLst/>
@@ -6431,7 +6459,7 @@
           <a:lstStyle/>
           <a:p>
             <a:r>
-              <a:rPr lang="en-US" i="1" dirty="0">
+              <a:rPr lang="en-US" sz="1900" i="1" dirty="0">
                 <a:solidFill>
                   <a:schemeClr val="bg1">
                     <a:lumMod val="50000"/>
@@ -6445,7 +6473,7 @@
           </a:p>
           <a:p>
             <a:r>
-              <a:rPr lang="en-US" i="1" dirty="0">
+              <a:rPr lang="en-US" sz="1900" i="1" dirty="0">
                 <a:solidFill>
                   <a:schemeClr val="bg1">
                     <a:lumMod val="50000"/>
@@ -6454,7 +6482,7 @@
                 <a:latin typeface="Times New Roman" panose="02020603050405020304" pitchFamily="18" charset="0"/>
                 <a:cs typeface="Times New Roman" panose="02020603050405020304" pitchFamily="18" charset="0"/>
               </a:rPr>
-              <a:t>private data</a:t>
+              <a:t>private data write set</a:t>
             </a:r>
           </a:p>
         </p:txBody>
@@ -6516,7 +6544,7 @@
           <a:p>
             <a:pPr algn="ctr"/>
             <a:r>
-              <a:rPr lang="en-US" sz="1400" dirty="0"/>
+              <a:rPr lang="en-US" sz="1700" dirty="0"/>
               <a:t>3</a:t>
             </a:r>
           </a:p>
@@ -6579,7 +6607,7 @@
           <a:p>
             <a:pPr algn="ctr"/>
             <a:r>
-              <a:rPr lang="en-US" sz="1400" dirty="0"/>
+              <a:rPr lang="en-US" sz="1700" dirty="0"/>
               <a:t>3</a:t>
             </a:r>
           </a:p>
@@ -6599,7 +6627,7 @@
         </p:nvSpPr>
         <p:spPr>
           <a:xfrm>
-            <a:off x="2789403" y="2944593"/>
+            <a:off x="3354879" y="2968657"/>
             <a:ext cx="185195" cy="206143"/>
           </a:xfrm>
           <a:prstGeom prst="ellipse">
@@ -6642,7 +6670,7 @@
           <a:p>
             <a:pPr algn="ctr"/>
             <a:r>
-              <a:rPr lang="en-US" sz="1400" dirty="0"/>
+              <a:rPr lang="en-US" sz="1700" dirty="0"/>
               <a:t>5</a:t>
             </a:r>
           </a:p>
@@ -6705,7 +6733,7 @@
           <a:p>
             <a:pPr algn="ctr"/>
             <a:r>
-              <a:rPr lang="en-US" sz="1400" dirty="0"/>
+              <a:rPr lang="en-US" sz="1700" dirty="0"/>
               <a:t>9</a:t>
             </a:r>
           </a:p>
@@ -6768,7 +6796,7 @@
           <a:p>
             <a:pPr algn="ctr"/>
             <a:r>
-              <a:rPr lang="en-US" sz="1400" dirty="0"/>
+              <a:rPr lang="en-US" sz="1700" dirty="0"/>
               <a:t>9</a:t>
             </a:r>
           </a:p>
@@ -6788,8 +6816,8 @@
         </p:nvSpPr>
         <p:spPr>
           <a:xfrm>
-            <a:off x="4458557" y="4758288"/>
-            <a:ext cx="4237057" cy="646331"/>
+            <a:off x="5245322" y="4758288"/>
+            <a:ext cx="4482317" cy="677108"/>
           </a:xfrm>
           <a:prstGeom prst="rect">
             <a:avLst/>
@@ -6803,7 +6831,7 @@
           <a:lstStyle/>
           <a:p>
             <a:r>
-              <a:rPr lang="en-US" dirty="0">
+              <a:rPr lang="en-US" sz="1900" dirty="0">
                 <a:solidFill>
                   <a:schemeClr val="bg2">
                     <a:lumMod val="50000"/>
@@ -6815,7 +6843,7 @@
               <a:t>fetch private data matching the hashed data</a:t>
             </a:r>
             <a:br>
-              <a:rPr lang="en-US" dirty="0">
+              <a:rPr lang="en-US" sz="1900" dirty="0">
                 <a:solidFill>
                   <a:schemeClr val="bg2">
                     <a:lumMod val="50000"/>
@@ -6826,7 +6854,7 @@
               </a:rPr>
             </a:br>
             <a:r>
-              <a:rPr lang="en-US" dirty="0">
+              <a:rPr lang="en-US" sz="1900" dirty="0">
                 <a:solidFill>
                   <a:schemeClr val="bg2">
                     <a:lumMod val="50000"/>
@@ -6917,7 +6945,7 @@
         </p:nvSpPr>
         <p:spPr>
           <a:xfrm>
-            <a:off x="9456886" y="5482753"/>
+            <a:off x="9536398" y="5482753"/>
             <a:ext cx="185195" cy="206143"/>
           </a:xfrm>
           <a:prstGeom prst="ellipse">
@@ -6960,7 +6988,7 @@
           <a:p>
             <a:pPr algn="ctr"/>
             <a:r>
-              <a:rPr lang="en-US" sz="1400" dirty="0"/>
+              <a:rPr lang="en-US" sz="1700" dirty="0"/>
               <a:t>9</a:t>
             </a:r>
           </a:p>
@@ -6980,8 +7008,8 @@
         </p:nvSpPr>
         <p:spPr>
           <a:xfrm>
-            <a:off x="8823192" y="5593761"/>
-            <a:ext cx="1582484" cy="646331"/>
+            <a:off x="9293214" y="5593761"/>
+            <a:ext cx="1656223" cy="677108"/>
           </a:xfrm>
           <a:prstGeom prst="rect">
             <a:avLst/>
@@ -6996,7 +7024,7 @@
           <a:p>
             <a:pPr algn="ctr"/>
             <a:r>
-              <a:rPr lang="en-US" dirty="0">
+              <a:rPr lang="en-US" sz="1900" dirty="0">
                 <a:solidFill>
                   <a:schemeClr val="bg2">
                     <a:lumMod val="50000"/>
@@ -7008,7 +7036,7 @@
               <a:t>commit public </a:t>
             </a:r>
             <a:br>
-              <a:rPr lang="en-US" dirty="0">
+              <a:rPr lang="en-US" sz="1900" dirty="0">
                 <a:solidFill>
                   <a:schemeClr val="bg2">
                     <a:lumMod val="50000"/>
@@ -7019,7 +7047,7 @@
               </a:rPr>
             </a:br>
             <a:r>
-              <a:rPr lang="en-US" dirty="0">
+              <a:rPr lang="en-US" sz="1900" dirty="0">
                 <a:solidFill>
                   <a:schemeClr val="bg2">
                     <a:lumMod val="50000"/>
@@ -7110,8 +7138,8 @@
         </p:nvSpPr>
         <p:spPr>
           <a:xfrm>
-            <a:off x="4462673" y="6104514"/>
-            <a:ext cx="3997636" cy="369332"/>
+            <a:off x="4889009" y="6104514"/>
+            <a:ext cx="4724220" cy="384721"/>
           </a:xfrm>
           <a:prstGeom prst="rect">
             <a:avLst/>
@@ -7126,7 +7154,7 @@
           <a:p>
             <a:pPr algn="ctr"/>
             <a:r>
-              <a:rPr lang="en-US" dirty="0">
+              <a:rPr lang="en-US" sz="1900" dirty="0">
                 <a:solidFill>
                   <a:schemeClr val="bg2">
                     <a:lumMod val="50000"/>
@@ -7262,6 +7290,1021 @@
             <a:r>
               <a:rPr lang="en-US" sz="1400" dirty="0"/>
               <a:t>11</a:t>
+            </a:r>
+          </a:p>
+        </p:txBody>
+      </p:sp>
+      <p:sp>
+        <p:nvSpPr>
+          <p:cNvPr id="2" name="TextBox 1">
+            <a:extLst>
+              <a:ext uri="{FF2B5EF4-FFF2-40B4-BE49-F238E27FC236}">
+                <a16:creationId xmlns:a16="http://schemas.microsoft.com/office/drawing/2014/main" id="{2379F68F-E151-8342-8083-FFD9CD257835}"/>
+              </a:ext>
+            </a:extLst>
+          </p:cNvPr>
+          <p:cNvSpPr txBox="1"/>
+          <p:nvPr/>
+        </p:nvSpPr>
+        <p:spPr>
+          <a:xfrm>
+            <a:off x="3390025" y="719077"/>
+            <a:ext cx="1492140" cy="369332"/>
+          </a:xfrm>
+          <a:prstGeom prst="rect">
+            <a:avLst/>
+          </a:prstGeom>
+          <a:noFill/>
+        </p:spPr>
+        <p:txBody>
+          <a:bodyPr wrap="none" rtlCol="0">
+            <a:spAutoFit/>
+          </a:bodyPr>
+          <a:lstStyle/>
+          <a:p>
+            <a:r>
+              <a:rPr lang="en-US" dirty="0"/>
+              <a:t>transient data</a:t>
+            </a:r>
+          </a:p>
+        </p:txBody>
+      </p:sp>
+      <p:cxnSp>
+        <p:nvCxnSpPr>
+          <p:cNvPr id="25" name="Straight Arrow Connector 24">
+            <a:extLst>
+              <a:ext uri="{FF2B5EF4-FFF2-40B4-BE49-F238E27FC236}">
+                <a16:creationId xmlns:a16="http://schemas.microsoft.com/office/drawing/2014/main" id="{03CAC658-A582-A543-84CF-552C4D4236EC}"/>
+              </a:ext>
+            </a:extLst>
+          </p:cNvPr>
+          <p:cNvCxnSpPr>
+            <a:cxnSpLocks/>
+          </p:cNvCxnSpPr>
+          <p:nvPr/>
+        </p:nvCxnSpPr>
+        <p:spPr>
+          <a:xfrm>
+            <a:off x="4136095" y="1018836"/>
+            <a:ext cx="0" cy="193260"/>
+          </a:xfrm>
+          <a:prstGeom prst="straightConnector1">
+            <a:avLst/>
+          </a:prstGeom>
+          <a:ln>
+            <a:solidFill>
+              <a:schemeClr val="tx1"/>
+            </a:solidFill>
+            <a:tailEnd type="triangle"/>
+          </a:ln>
+        </p:spPr>
+        <p:style>
+          <a:lnRef idx="1">
+            <a:schemeClr val="accent1"/>
+          </a:lnRef>
+          <a:fillRef idx="0">
+            <a:schemeClr val="accent1"/>
+          </a:fillRef>
+          <a:effectRef idx="0">
+            <a:schemeClr val="accent1"/>
+          </a:effectRef>
+          <a:fontRef idx="minor">
+            <a:schemeClr val="tx1"/>
+          </a:fontRef>
+        </p:style>
+      </p:cxnSp>
+      <p:sp>
+        <p:nvSpPr>
+          <p:cNvPr id="61" name="Rectangle 60">
+            <a:extLst>
+              <a:ext uri="{FF2B5EF4-FFF2-40B4-BE49-F238E27FC236}">
+                <a16:creationId xmlns:a16="http://schemas.microsoft.com/office/drawing/2014/main" id="{C0BB95A4-7AAF-7848-9EAA-CEF373B67521}"/>
+              </a:ext>
+            </a:extLst>
+          </p:cNvPr>
+          <p:cNvSpPr/>
+          <p:nvPr/>
+        </p:nvSpPr>
+        <p:spPr>
+          <a:xfrm>
+            <a:off x="2497739" y="4816705"/>
+            <a:ext cx="2637055" cy="1122352"/>
+          </a:xfrm>
+          <a:prstGeom prst="rect">
+            <a:avLst/>
+          </a:prstGeom>
+          <a:solidFill>
+            <a:schemeClr val="bg1">
+              <a:lumMod val="95000"/>
+            </a:schemeClr>
+          </a:solidFill>
+          <a:ln>
+            <a:solidFill>
+              <a:schemeClr val="bg1"/>
+            </a:solidFill>
+          </a:ln>
+        </p:spPr>
+        <p:style>
+          <a:lnRef idx="2">
+            <a:schemeClr val="accent1">
+              <a:shade val="50000"/>
+            </a:schemeClr>
+          </a:lnRef>
+          <a:fillRef idx="1">
+            <a:schemeClr val="accent1"/>
+          </a:fillRef>
+          <a:effectRef idx="0">
+            <a:schemeClr val="accent1"/>
+          </a:effectRef>
+          <a:fontRef idx="minor">
+            <a:schemeClr val="lt1"/>
+          </a:fontRef>
+        </p:style>
+        <p:txBody>
+          <a:bodyPr rtlCol="0" anchor="ctr"/>
+          <a:lstStyle/>
+          <a:p>
+            <a:pPr algn="ctr"/>
+            <a:endParaRPr lang="en-US"/>
+          </a:p>
+        </p:txBody>
+      </p:sp>
+      <p:sp>
+        <p:nvSpPr>
+          <p:cNvPr id="62" name="Oval 61">
+            <a:extLst>
+              <a:ext uri="{FF2B5EF4-FFF2-40B4-BE49-F238E27FC236}">
+                <a16:creationId xmlns:a16="http://schemas.microsoft.com/office/drawing/2014/main" id="{B87CC442-EA3D-B244-8612-36BCE875F7DD}"/>
+              </a:ext>
+            </a:extLst>
+          </p:cNvPr>
+          <p:cNvSpPr/>
+          <p:nvPr/>
+        </p:nvSpPr>
+        <p:spPr>
+          <a:xfrm>
+            <a:off x="2784031" y="4871400"/>
+            <a:ext cx="185195" cy="206143"/>
+          </a:xfrm>
+          <a:prstGeom prst="ellipse">
+            <a:avLst/>
+          </a:prstGeom>
+          <a:solidFill>
+            <a:schemeClr val="tx1">
+              <a:lumMod val="65000"/>
+              <a:lumOff val="35000"/>
+            </a:schemeClr>
+          </a:solidFill>
+          <a:ln>
+            <a:solidFill>
+              <a:schemeClr val="tx1">
+                <a:lumMod val="65000"/>
+                <a:lumOff val="35000"/>
+              </a:schemeClr>
+            </a:solidFill>
+          </a:ln>
+        </p:spPr>
+        <p:style>
+          <a:lnRef idx="2">
+            <a:schemeClr val="accent1">
+              <a:shade val="50000"/>
+            </a:schemeClr>
+          </a:lnRef>
+          <a:fillRef idx="1">
+            <a:schemeClr val="accent1"/>
+          </a:fillRef>
+          <a:effectRef idx="0">
+            <a:schemeClr val="accent1"/>
+          </a:effectRef>
+          <a:fontRef idx="minor">
+            <a:schemeClr val="lt1"/>
+          </a:fontRef>
+        </p:style>
+        <p:txBody>
+          <a:bodyPr rtlCol="0" anchor="ctr"/>
+          <a:lstStyle/>
+          <a:p>
+            <a:pPr algn="ctr"/>
+            <a:r>
+              <a:rPr lang="en-US" sz="1700" dirty="0"/>
+              <a:t>1</a:t>
+            </a:r>
+          </a:p>
+        </p:txBody>
+      </p:sp>
+      <p:sp>
+        <p:nvSpPr>
+          <p:cNvPr id="64" name="Oval 63">
+            <a:extLst>
+              <a:ext uri="{FF2B5EF4-FFF2-40B4-BE49-F238E27FC236}">
+                <a16:creationId xmlns:a16="http://schemas.microsoft.com/office/drawing/2014/main" id="{77DA7095-E8EC-A940-996A-15DDB814E152}"/>
+              </a:ext>
+            </a:extLst>
+          </p:cNvPr>
+          <p:cNvSpPr/>
+          <p:nvPr/>
+        </p:nvSpPr>
+        <p:spPr>
+          <a:xfrm>
+            <a:off x="3056039" y="4868820"/>
+            <a:ext cx="185195" cy="206143"/>
+          </a:xfrm>
+          <a:prstGeom prst="ellipse">
+            <a:avLst/>
+          </a:prstGeom>
+          <a:solidFill>
+            <a:schemeClr val="tx1">
+              <a:lumMod val="65000"/>
+              <a:lumOff val="35000"/>
+            </a:schemeClr>
+          </a:solidFill>
+          <a:ln>
+            <a:solidFill>
+              <a:schemeClr val="tx1">
+                <a:lumMod val="65000"/>
+                <a:lumOff val="35000"/>
+              </a:schemeClr>
+            </a:solidFill>
+          </a:ln>
+        </p:spPr>
+        <p:style>
+          <a:lnRef idx="2">
+            <a:schemeClr val="accent1">
+              <a:shade val="50000"/>
+            </a:schemeClr>
+          </a:lnRef>
+          <a:fillRef idx="1">
+            <a:schemeClr val="accent1"/>
+          </a:fillRef>
+          <a:effectRef idx="0">
+            <a:schemeClr val="accent1"/>
+          </a:effectRef>
+          <a:fontRef idx="minor">
+            <a:schemeClr val="lt1"/>
+          </a:fontRef>
+        </p:style>
+        <p:txBody>
+          <a:bodyPr rtlCol="0" anchor="ctr"/>
+          <a:lstStyle/>
+          <a:p>
+            <a:pPr algn="ctr"/>
+            <a:r>
+              <a:rPr lang="en-US" sz="1700" dirty="0"/>
+              <a:t>2</a:t>
+            </a:r>
+          </a:p>
+        </p:txBody>
+      </p:sp>
+      <p:sp>
+        <p:nvSpPr>
+          <p:cNvPr id="66" name="Oval 65">
+            <a:extLst>
+              <a:ext uri="{FF2B5EF4-FFF2-40B4-BE49-F238E27FC236}">
+                <a16:creationId xmlns:a16="http://schemas.microsoft.com/office/drawing/2014/main" id="{05C43F74-9192-5A42-A400-782AB907C87A}"/>
+              </a:ext>
+            </a:extLst>
+          </p:cNvPr>
+          <p:cNvSpPr/>
+          <p:nvPr/>
+        </p:nvSpPr>
+        <p:spPr>
+          <a:xfrm>
+            <a:off x="3324117" y="5127119"/>
+            <a:ext cx="185195" cy="206143"/>
+          </a:xfrm>
+          <a:prstGeom prst="ellipse">
+            <a:avLst/>
+          </a:prstGeom>
+          <a:solidFill>
+            <a:schemeClr val="tx1">
+              <a:lumMod val="65000"/>
+              <a:lumOff val="35000"/>
+            </a:schemeClr>
+          </a:solidFill>
+          <a:ln>
+            <a:solidFill>
+              <a:schemeClr val="tx1">
+                <a:lumMod val="65000"/>
+                <a:lumOff val="35000"/>
+              </a:schemeClr>
+            </a:solidFill>
+          </a:ln>
+        </p:spPr>
+        <p:style>
+          <a:lnRef idx="2">
+            <a:schemeClr val="accent1">
+              <a:shade val="50000"/>
+            </a:schemeClr>
+          </a:lnRef>
+          <a:fillRef idx="1">
+            <a:schemeClr val="accent1"/>
+          </a:fillRef>
+          <a:effectRef idx="0">
+            <a:schemeClr val="accent1"/>
+          </a:effectRef>
+          <a:fontRef idx="minor">
+            <a:schemeClr val="lt1"/>
+          </a:fontRef>
+        </p:style>
+        <p:txBody>
+          <a:bodyPr rtlCol="0" anchor="ctr"/>
+          <a:lstStyle/>
+          <a:p>
+            <a:pPr algn="ctr"/>
+            <a:r>
+              <a:rPr lang="en-US" sz="1700" dirty="0"/>
+              <a:t>6</a:t>
+            </a:r>
+          </a:p>
+        </p:txBody>
+      </p:sp>
+      <p:sp>
+        <p:nvSpPr>
+          <p:cNvPr id="67" name="Oval 66">
+            <a:extLst>
+              <a:ext uri="{FF2B5EF4-FFF2-40B4-BE49-F238E27FC236}">
+                <a16:creationId xmlns:a16="http://schemas.microsoft.com/office/drawing/2014/main" id="{E07B9024-D68A-DD40-A0A8-9A5EC37CF4B2}"/>
+              </a:ext>
+            </a:extLst>
+          </p:cNvPr>
+          <p:cNvSpPr/>
+          <p:nvPr/>
+        </p:nvSpPr>
+        <p:spPr>
+          <a:xfrm>
+            <a:off x="3590561" y="5372509"/>
+            <a:ext cx="185195" cy="206143"/>
+          </a:xfrm>
+          <a:prstGeom prst="ellipse">
+            <a:avLst/>
+          </a:prstGeom>
+          <a:solidFill>
+            <a:schemeClr val="tx1">
+              <a:lumMod val="65000"/>
+              <a:lumOff val="35000"/>
+            </a:schemeClr>
+          </a:solidFill>
+          <a:ln>
+            <a:solidFill>
+              <a:schemeClr val="tx1">
+                <a:lumMod val="65000"/>
+                <a:lumOff val="35000"/>
+              </a:schemeClr>
+            </a:solidFill>
+          </a:ln>
+        </p:spPr>
+        <p:style>
+          <a:lnRef idx="2">
+            <a:schemeClr val="accent1">
+              <a:shade val="50000"/>
+            </a:schemeClr>
+          </a:lnRef>
+          <a:fillRef idx="1">
+            <a:schemeClr val="accent1"/>
+          </a:fillRef>
+          <a:effectRef idx="0">
+            <a:schemeClr val="accent1"/>
+          </a:effectRef>
+          <a:fontRef idx="minor">
+            <a:schemeClr val="lt1"/>
+          </a:fontRef>
+        </p:style>
+        <p:txBody>
+          <a:bodyPr rtlCol="0" anchor="ctr"/>
+          <a:lstStyle/>
+          <a:p>
+            <a:pPr algn="ctr"/>
+            <a:r>
+              <a:rPr lang="en-US" sz="1700" dirty="0"/>
+              <a:t>8</a:t>
+            </a:r>
+          </a:p>
+        </p:txBody>
+      </p:sp>
+      <p:sp>
+        <p:nvSpPr>
+          <p:cNvPr id="69" name="TextBox 68">
+            <a:extLst>
+              <a:ext uri="{FF2B5EF4-FFF2-40B4-BE49-F238E27FC236}">
+                <a16:creationId xmlns:a16="http://schemas.microsoft.com/office/drawing/2014/main" id="{E68F7745-FD66-FC44-B66F-157D6393A55E}"/>
+              </a:ext>
+            </a:extLst>
+          </p:cNvPr>
+          <p:cNvSpPr txBox="1"/>
+          <p:nvPr/>
+        </p:nvSpPr>
+        <p:spPr>
+          <a:xfrm>
+            <a:off x="3947883" y="4786991"/>
+            <a:ext cx="1197764" cy="369332"/>
+          </a:xfrm>
+          <a:prstGeom prst="rect">
+            <a:avLst/>
+          </a:prstGeom>
+          <a:noFill/>
+        </p:spPr>
+        <p:txBody>
+          <a:bodyPr wrap="none" rtlCol="0">
+            <a:spAutoFit/>
+          </a:bodyPr>
+          <a:lstStyle/>
+          <a:p>
+            <a:r>
+              <a:rPr lang="en-US" dirty="0">
+                <a:latin typeface="Times New Roman" panose="02020603050405020304" pitchFamily="18" charset="0"/>
+                <a:cs typeface="Times New Roman" panose="02020603050405020304" pitchFamily="18" charset="0"/>
+              </a:rPr>
+              <a:t>Simulation</a:t>
+            </a:r>
+          </a:p>
+        </p:txBody>
+      </p:sp>
+      <p:sp>
+        <p:nvSpPr>
+          <p:cNvPr id="70" name="TextBox 69">
+            <a:extLst>
+              <a:ext uri="{FF2B5EF4-FFF2-40B4-BE49-F238E27FC236}">
+                <a16:creationId xmlns:a16="http://schemas.microsoft.com/office/drawing/2014/main" id="{33C54BEE-03DA-8447-9DE8-9C59A5D94D55}"/>
+              </a:ext>
+            </a:extLst>
+          </p:cNvPr>
+          <p:cNvSpPr txBox="1"/>
+          <p:nvPr/>
+        </p:nvSpPr>
+        <p:spPr>
+          <a:xfrm>
+            <a:off x="3929802" y="5047878"/>
+            <a:ext cx="1018227" cy="369332"/>
+          </a:xfrm>
+          <a:prstGeom prst="rect">
+            <a:avLst/>
+          </a:prstGeom>
+          <a:noFill/>
+        </p:spPr>
+        <p:txBody>
+          <a:bodyPr wrap="none" rtlCol="0">
+            <a:spAutoFit/>
+          </a:bodyPr>
+          <a:lstStyle/>
+          <a:p>
+            <a:r>
+              <a:rPr lang="en-US" dirty="0">
+                <a:latin typeface="Times New Roman" panose="02020603050405020304" pitchFamily="18" charset="0"/>
+                <a:cs typeface="Times New Roman" panose="02020603050405020304" pitchFamily="18" charset="0"/>
+              </a:rPr>
+              <a:t>Ordering</a:t>
+            </a:r>
+          </a:p>
+        </p:txBody>
+      </p:sp>
+      <p:sp>
+        <p:nvSpPr>
+          <p:cNvPr id="71" name="TextBox 70">
+            <a:extLst>
+              <a:ext uri="{FF2B5EF4-FFF2-40B4-BE49-F238E27FC236}">
+                <a16:creationId xmlns:a16="http://schemas.microsoft.com/office/drawing/2014/main" id="{A3CFB16B-10DA-964A-8374-AAB4A026AB50}"/>
+              </a:ext>
+            </a:extLst>
+          </p:cNvPr>
+          <p:cNvSpPr txBox="1"/>
+          <p:nvPr/>
+        </p:nvSpPr>
+        <p:spPr>
+          <a:xfrm>
+            <a:off x="3927224" y="5324262"/>
+            <a:ext cx="1133708" cy="369332"/>
+          </a:xfrm>
+          <a:prstGeom prst="rect">
+            <a:avLst/>
+          </a:prstGeom>
+          <a:noFill/>
+        </p:spPr>
+        <p:txBody>
+          <a:bodyPr wrap="none" rtlCol="0">
+            <a:spAutoFit/>
+          </a:bodyPr>
+          <a:lstStyle/>
+          <a:p>
+            <a:r>
+              <a:rPr lang="en-US" dirty="0">
+                <a:latin typeface="Times New Roman" panose="02020603050405020304" pitchFamily="18" charset="0"/>
+                <a:cs typeface="Times New Roman" panose="02020603050405020304" pitchFamily="18" charset="0"/>
+              </a:rPr>
+              <a:t>Validation</a:t>
+            </a:r>
+          </a:p>
+        </p:txBody>
+      </p:sp>
+      <p:sp>
+        <p:nvSpPr>
+          <p:cNvPr id="72" name="Oval 71">
+            <a:extLst>
+              <a:ext uri="{FF2B5EF4-FFF2-40B4-BE49-F238E27FC236}">
+                <a16:creationId xmlns:a16="http://schemas.microsoft.com/office/drawing/2014/main" id="{E8DEBB6F-A506-2042-8A0D-8DBAF13B8CD9}"/>
+              </a:ext>
+            </a:extLst>
+          </p:cNvPr>
+          <p:cNvSpPr/>
+          <p:nvPr/>
+        </p:nvSpPr>
+        <p:spPr>
+          <a:xfrm>
+            <a:off x="3050312" y="5132286"/>
+            <a:ext cx="185195" cy="206143"/>
+          </a:xfrm>
+          <a:prstGeom prst="ellipse">
+            <a:avLst/>
+          </a:prstGeom>
+          <a:solidFill>
+            <a:schemeClr val="tx1">
+              <a:lumMod val="65000"/>
+              <a:lumOff val="35000"/>
+            </a:schemeClr>
+          </a:solidFill>
+          <a:ln>
+            <a:solidFill>
+              <a:schemeClr val="tx1">
+                <a:lumMod val="65000"/>
+                <a:lumOff val="35000"/>
+              </a:schemeClr>
+            </a:solidFill>
+          </a:ln>
+        </p:spPr>
+        <p:style>
+          <a:lnRef idx="2">
+            <a:schemeClr val="accent1">
+              <a:shade val="50000"/>
+            </a:schemeClr>
+          </a:lnRef>
+          <a:fillRef idx="1">
+            <a:schemeClr val="accent1"/>
+          </a:fillRef>
+          <a:effectRef idx="0">
+            <a:schemeClr val="accent1"/>
+          </a:effectRef>
+          <a:fontRef idx="minor">
+            <a:schemeClr val="lt1"/>
+          </a:fontRef>
+        </p:style>
+        <p:txBody>
+          <a:bodyPr rtlCol="0" anchor="ctr"/>
+          <a:lstStyle/>
+          <a:p>
+            <a:pPr algn="ctr"/>
+            <a:r>
+              <a:rPr lang="en-US" sz="1700" dirty="0"/>
+              <a:t>5</a:t>
+            </a:r>
+          </a:p>
+        </p:txBody>
+      </p:sp>
+      <p:sp>
+        <p:nvSpPr>
+          <p:cNvPr id="75" name="Oval 74">
+            <a:extLst>
+              <a:ext uri="{FF2B5EF4-FFF2-40B4-BE49-F238E27FC236}">
+                <a16:creationId xmlns:a16="http://schemas.microsoft.com/office/drawing/2014/main" id="{77FDB65A-BD31-D349-AF26-4114A7021FD4}"/>
+              </a:ext>
+            </a:extLst>
+          </p:cNvPr>
+          <p:cNvSpPr/>
+          <p:nvPr/>
+        </p:nvSpPr>
+        <p:spPr>
+          <a:xfrm>
+            <a:off x="3600501" y="5124539"/>
+            <a:ext cx="185195" cy="206143"/>
+          </a:xfrm>
+          <a:prstGeom prst="ellipse">
+            <a:avLst/>
+          </a:prstGeom>
+          <a:solidFill>
+            <a:schemeClr val="tx1">
+              <a:lumMod val="65000"/>
+              <a:lumOff val="35000"/>
+            </a:schemeClr>
+          </a:solidFill>
+          <a:ln>
+            <a:solidFill>
+              <a:schemeClr val="tx1">
+                <a:lumMod val="65000"/>
+                <a:lumOff val="35000"/>
+              </a:schemeClr>
+            </a:solidFill>
+          </a:ln>
+        </p:spPr>
+        <p:style>
+          <a:lnRef idx="2">
+            <a:schemeClr val="accent1">
+              <a:shade val="50000"/>
+            </a:schemeClr>
+          </a:lnRef>
+          <a:fillRef idx="1">
+            <a:schemeClr val="accent1"/>
+          </a:fillRef>
+          <a:effectRef idx="0">
+            <a:schemeClr val="accent1"/>
+          </a:effectRef>
+          <a:fontRef idx="minor">
+            <a:schemeClr val="lt1"/>
+          </a:fontRef>
+        </p:style>
+        <p:txBody>
+          <a:bodyPr rtlCol="0" anchor="ctr"/>
+          <a:lstStyle/>
+          <a:p>
+            <a:pPr algn="ctr"/>
+            <a:r>
+              <a:rPr lang="en-US" sz="1700" dirty="0"/>
+              <a:t>7</a:t>
+            </a:r>
+          </a:p>
+        </p:txBody>
+      </p:sp>
+      <p:sp>
+        <p:nvSpPr>
+          <p:cNvPr id="78" name="TextBox 77">
+            <a:extLst>
+              <a:ext uri="{FF2B5EF4-FFF2-40B4-BE49-F238E27FC236}">
+                <a16:creationId xmlns:a16="http://schemas.microsoft.com/office/drawing/2014/main" id="{921D7B83-6226-DF4A-B3CB-83B60FCF606B}"/>
+              </a:ext>
+            </a:extLst>
+          </p:cNvPr>
+          <p:cNvSpPr txBox="1"/>
+          <p:nvPr/>
+        </p:nvSpPr>
+        <p:spPr>
+          <a:xfrm>
+            <a:off x="3924643" y="5585148"/>
+            <a:ext cx="941283" cy="369332"/>
+          </a:xfrm>
+          <a:prstGeom prst="rect">
+            <a:avLst/>
+          </a:prstGeom>
+          <a:noFill/>
+        </p:spPr>
+        <p:txBody>
+          <a:bodyPr wrap="none" rtlCol="0">
+            <a:spAutoFit/>
+          </a:bodyPr>
+          <a:lstStyle/>
+          <a:p>
+            <a:r>
+              <a:rPr lang="en-US" dirty="0">
+                <a:latin typeface="Times New Roman" panose="02020603050405020304" pitchFamily="18" charset="0"/>
+                <a:cs typeface="Times New Roman" panose="02020603050405020304" pitchFamily="18" charset="0"/>
+              </a:rPr>
+              <a:t>Commit</a:t>
+            </a:r>
+          </a:p>
+        </p:txBody>
+      </p:sp>
+      <p:sp>
+        <p:nvSpPr>
+          <p:cNvPr id="79" name="Oval 78">
+            <a:extLst>
+              <a:ext uri="{FF2B5EF4-FFF2-40B4-BE49-F238E27FC236}">
+                <a16:creationId xmlns:a16="http://schemas.microsoft.com/office/drawing/2014/main" id="{E32970E5-B214-DD4C-91EA-E0E017F44D35}"/>
+              </a:ext>
+            </a:extLst>
+          </p:cNvPr>
+          <p:cNvSpPr/>
+          <p:nvPr/>
+        </p:nvSpPr>
+        <p:spPr>
+          <a:xfrm>
+            <a:off x="3327707" y="4872135"/>
+            <a:ext cx="185195" cy="206143"/>
+          </a:xfrm>
+          <a:prstGeom prst="ellipse">
+            <a:avLst/>
+          </a:prstGeom>
+          <a:solidFill>
+            <a:schemeClr val="tx1">
+              <a:lumMod val="65000"/>
+              <a:lumOff val="35000"/>
+            </a:schemeClr>
+          </a:solidFill>
+          <a:ln>
+            <a:solidFill>
+              <a:schemeClr val="tx1">
+                <a:lumMod val="65000"/>
+                <a:lumOff val="35000"/>
+              </a:schemeClr>
+            </a:solidFill>
+          </a:ln>
+        </p:spPr>
+        <p:style>
+          <a:lnRef idx="2">
+            <a:schemeClr val="accent1">
+              <a:shade val="50000"/>
+            </a:schemeClr>
+          </a:lnRef>
+          <a:fillRef idx="1">
+            <a:schemeClr val="accent1"/>
+          </a:fillRef>
+          <a:effectRef idx="0">
+            <a:schemeClr val="accent1"/>
+          </a:effectRef>
+          <a:fontRef idx="minor">
+            <a:schemeClr val="lt1"/>
+          </a:fontRef>
+        </p:style>
+        <p:txBody>
+          <a:bodyPr rtlCol="0" anchor="ctr"/>
+          <a:lstStyle/>
+          <a:p>
+            <a:pPr algn="ctr"/>
+            <a:r>
+              <a:rPr lang="en-US" sz="1700" dirty="0"/>
+              <a:t>3</a:t>
+            </a:r>
+          </a:p>
+        </p:txBody>
+      </p:sp>
+      <p:sp>
+        <p:nvSpPr>
+          <p:cNvPr id="82" name="Oval 81">
+            <a:extLst>
+              <a:ext uri="{FF2B5EF4-FFF2-40B4-BE49-F238E27FC236}">
+                <a16:creationId xmlns:a16="http://schemas.microsoft.com/office/drawing/2014/main" id="{800DF174-109C-6547-BC6E-7679B18004FB}"/>
+              </a:ext>
+            </a:extLst>
+          </p:cNvPr>
+          <p:cNvSpPr/>
+          <p:nvPr/>
+        </p:nvSpPr>
+        <p:spPr>
+          <a:xfrm>
+            <a:off x="3595241" y="4874993"/>
+            <a:ext cx="185195" cy="206143"/>
+          </a:xfrm>
+          <a:prstGeom prst="ellipse">
+            <a:avLst/>
+          </a:prstGeom>
+          <a:solidFill>
+            <a:schemeClr val="tx1">
+              <a:lumMod val="65000"/>
+              <a:lumOff val="35000"/>
+            </a:schemeClr>
+          </a:solidFill>
+          <a:ln>
+            <a:solidFill>
+              <a:schemeClr val="tx1">
+                <a:lumMod val="65000"/>
+                <a:lumOff val="35000"/>
+              </a:schemeClr>
+            </a:solidFill>
+          </a:ln>
+        </p:spPr>
+        <p:style>
+          <a:lnRef idx="2">
+            <a:schemeClr val="accent1">
+              <a:shade val="50000"/>
+            </a:schemeClr>
+          </a:lnRef>
+          <a:fillRef idx="1">
+            <a:schemeClr val="accent1"/>
+          </a:fillRef>
+          <a:effectRef idx="0">
+            <a:schemeClr val="accent1"/>
+          </a:effectRef>
+          <a:fontRef idx="minor">
+            <a:schemeClr val="lt1"/>
+          </a:fontRef>
+        </p:style>
+        <p:txBody>
+          <a:bodyPr rtlCol="0" anchor="ctr"/>
+          <a:lstStyle/>
+          <a:p>
+            <a:pPr algn="ctr"/>
+            <a:r>
+              <a:rPr lang="en-US" sz="1700" dirty="0"/>
+              <a:t>4</a:t>
+            </a:r>
+          </a:p>
+        </p:txBody>
+      </p:sp>
+      <p:sp>
+        <p:nvSpPr>
+          <p:cNvPr id="92" name="Oval 91">
+            <a:extLst>
+              <a:ext uri="{FF2B5EF4-FFF2-40B4-BE49-F238E27FC236}">
+                <a16:creationId xmlns:a16="http://schemas.microsoft.com/office/drawing/2014/main" id="{390D971F-8881-F846-884A-4299E5D5615E}"/>
+              </a:ext>
+            </a:extLst>
+          </p:cNvPr>
+          <p:cNvSpPr/>
+          <p:nvPr/>
+        </p:nvSpPr>
+        <p:spPr>
+          <a:xfrm>
+            <a:off x="2576555" y="5652429"/>
+            <a:ext cx="185195" cy="206143"/>
+          </a:xfrm>
+          <a:prstGeom prst="ellipse">
+            <a:avLst/>
+          </a:prstGeom>
+          <a:solidFill>
+            <a:schemeClr val="tx1">
+              <a:lumMod val="65000"/>
+              <a:lumOff val="35000"/>
+            </a:schemeClr>
+          </a:solidFill>
+          <a:ln>
+            <a:solidFill>
+              <a:schemeClr val="tx1">
+                <a:lumMod val="65000"/>
+                <a:lumOff val="35000"/>
+              </a:schemeClr>
+            </a:solidFill>
+          </a:ln>
+        </p:spPr>
+        <p:style>
+          <a:lnRef idx="2">
+            <a:schemeClr val="accent1">
+              <a:shade val="50000"/>
+            </a:schemeClr>
+          </a:lnRef>
+          <a:fillRef idx="1">
+            <a:schemeClr val="accent1"/>
+          </a:fillRef>
+          <a:effectRef idx="0">
+            <a:schemeClr val="accent1"/>
+          </a:effectRef>
+          <a:fontRef idx="minor">
+            <a:schemeClr val="lt1"/>
+          </a:fontRef>
+        </p:style>
+        <p:txBody>
+          <a:bodyPr rtlCol="0" anchor="ctr"/>
+          <a:lstStyle/>
+          <a:p>
+            <a:pPr algn="ctr"/>
+            <a:r>
+              <a:rPr lang="en-US" sz="1700" dirty="0"/>
+              <a:t>9</a:t>
+            </a:r>
+          </a:p>
+        </p:txBody>
+      </p:sp>
+      <p:sp>
+        <p:nvSpPr>
+          <p:cNvPr id="94" name="Oval 93">
+            <a:extLst>
+              <a:ext uri="{FF2B5EF4-FFF2-40B4-BE49-F238E27FC236}">
+                <a16:creationId xmlns:a16="http://schemas.microsoft.com/office/drawing/2014/main" id="{A2998A20-2F2F-1249-B2E1-9BD199EE19EF}"/>
+              </a:ext>
+            </a:extLst>
+          </p:cNvPr>
+          <p:cNvSpPr/>
+          <p:nvPr/>
+        </p:nvSpPr>
+        <p:spPr>
+          <a:xfrm>
+            <a:off x="2834719" y="5685243"/>
+            <a:ext cx="514800" cy="144000"/>
+          </a:xfrm>
+          <a:prstGeom prst="ellipse">
+            <a:avLst/>
+          </a:prstGeom>
+          <a:solidFill>
+            <a:schemeClr val="tx1">
+              <a:lumMod val="65000"/>
+              <a:lumOff val="35000"/>
+            </a:schemeClr>
+          </a:solidFill>
+          <a:ln>
+            <a:solidFill>
+              <a:schemeClr val="tx1">
+                <a:lumMod val="65000"/>
+                <a:lumOff val="35000"/>
+              </a:schemeClr>
+            </a:solidFill>
+          </a:ln>
+        </p:spPr>
+        <p:style>
+          <a:lnRef idx="2">
+            <a:schemeClr val="accent1">
+              <a:shade val="50000"/>
+            </a:schemeClr>
+          </a:lnRef>
+          <a:fillRef idx="1">
+            <a:schemeClr val="accent1"/>
+          </a:fillRef>
+          <a:effectRef idx="0">
+            <a:schemeClr val="accent1"/>
+          </a:effectRef>
+          <a:fontRef idx="minor">
+            <a:schemeClr val="lt1"/>
+          </a:fontRef>
+        </p:style>
+        <p:txBody>
+          <a:bodyPr rtlCol="0" anchor="ctr"/>
+          <a:lstStyle/>
+          <a:p>
+            <a:pPr algn="ctr"/>
+            <a:r>
+              <a:rPr lang="en-US" sz="1400" dirty="0"/>
+              <a:t>10</a:t>
+            </a:r>
+          </a:p>
+        </p:txBody>
+      </p:sp>
+      <p:sp>
+        <p:nvSpPr>
+          <p:cNvPr id="95" name="Oval 94">
+            <a:extLst>
+              <a:ext uri="{FF2B5EF4-FFF2-40B4-BE49-F238E27FC236}">
+                <a16:creationId xmlns:a16="http://schemas.microsoft.com/office/drawing/2014/main" id="{D92BFA49-FAE7-CC4B-B01F-02A5D343D120}"/>
+              </a:ext>
+            </a:extLst>
+          </p:cNvPr>
+          <p:cNvSpPr/>
+          <p:nvPr/>
+        </p:nvSpPr>
+        <p:spPr>
+          <a:xfrm>
+            <a:off x="3426297" y="5685243"/>
+            <a:ext cx="514800" cy="144000"/>
+          </a:xfrm>
+          <a:prstGeom prst="ellipse">
+            <a:avLst/>
+          </a:prstGeom>
+          <a:solidFill>
+            <a:schemeClr val="tx1">
+              <a:lumMod val="65000"/>
+              <a:lumOff val="35000"/>
+            </a:schemeClr>
+          </a:solidFill>
+          <a:ln>
+            <a:solidFill>
+              <a:schemeClr val="tx1">
+                <a:lumMod val="65000"/>
+                <a:lumOff val="35000"/>
+              </a:schemeClr>
+            </a:solidFill>
+          </a:ln>
+        </p:spPr>
+        <p:style>
+          <a:lnRef idx="2">
+            <a:schemeClr val="accent1">
+              <a:shade val="50000"/>
+            </a:schemeClr>
+          </a:lnRef>
+          <a:fillRef idx="1">
+            <a:schemeClr val="accent1"/>
+          </a:fillRef>
+          <a:effectRef idx="0">
+            <a:schemeClr val="accent1"/>
+          </a:effectRef>
+          <a:fontRef idx="minor">
+            <a:schemeClr val="lt1"/>
+          </a:fontRef>
+        </p:style>
+        <p:txBody>
+          <a:bodyPr rtlCol="0" anchor="ctr"/>
+          <a:lstStyle/>
+          <a:p>
+            <a:pPr algn="ctr"/>
+            <a:r>
+              <a:rPr lang="en-US" sz="1400" dirty="0"/>
+              <a:t>11</a:t>
+            </a:r>
+          </a:p>
+        </p:txBody>
+      </p:sp>
+      <p:sp>
+        <p:nvSpPr>
+          <p:cNvPr id="28" name="TextBox 27">
+            <a:extLst>
+              <a:ext uri="{FF2B5EF4-FFF2-40B4-BE49-F238E27FC236}">
+                <a16:creationId xmlns:a16="http://schemas.microsoft.com/office/drawing/2014/main" id="{7984054B-17B6-6042-8802-DDDF8B22D91D}"/>
+              </a:ext>
+            </a:extLst>
+          </p:cNvPr>
+          <p:cNvSpPr txBox="1"/>
+          <p:nvPr/>
+        </p:nvSpPr>
+        <p:spPr>
+          <a:xfrm>
+            <a:off x="3378205" y="4473659"/>
+            <a:ext cx="843501" cy="369332"/>
+          </a:xfrm>
+          <a:prstGeom prst="rect">
+            <a:avLst/>
+          </a:prstGeom>
+          <a:noFill/>
+        </p:spPr>
+        <p:txBody>
+          <a:bodyPr wrap="none" rtlCol="0">
+            <a:spAutoFit/>
+          </a:bodyPr>
+          <a:lstStyle/>
+          <a:p>
+            <a:r>
+              <a:rPr lang="en-US" b="1" dirty="0"/>
+              <a:t>phases</a:t>
             </a:r>
           </a:p>
         </p:txBody>

</xml_diff>